<commit_message>
Slides v3: real photo notes, stop-request chattering finding on slides 6 and 12
</commit_message>
<xml_diff>
--- a/presentation/FYP-assessment-presentation-v3.pptx
+++ b/presentation/FYP-assessment-presentation-v3.pptx
@@ -732,24 +732,16 @@
               <a:t>Luke | 30 seconds</a:t>
             </a:r>
           </a:p>
-          <a:p xmlns:a="http://schemas.openxmlformats.org/drawingml/2006/main">
-            <a:r>
-              <a:t/>
-            </a:r>
-          </a:p>
-          <a:p xmlns:a="http://schemas.openxmlformats.org/drawingml/2006/main">
-            <a:r>
-              <a:t>The contribution is a physical construction-task prototype that separates task recognition from geometric command limits and examines objective behaviour alongside experience. Dynamic speed control and task-aware safety already exist in prior research, so we do not claim to have invented them. We demonstrated integration and obtained useful descriptive findings, but have not established that predictive control improves safety or efficiency. The next comparison needs validated clearance and stopping measurements together with reliable controller exposure. Thank you; we welcome your questions.</a:t>
-            </a:r>
-          </a:p>
-          <a:p xmlns:a="http://schemas.openxmlformats.org/drawingml/2006/main">
-            <a:r>
-              <a:t/>
-            </a:r>
-          </a:p>
-          <a:p xmlns:a="http://schemas.openxmlformats.org/drawingml/2006/main">
-            <a:r>
-              <a:t>Sources: Paper Related Work and Conclusion; Byner et al. (2019), doi:10.1016/j.rcim.2018.11.002; Xiao Lin et al. (2026), doi:10.1016/j.autcon.2026.107067.</a:t>
+          <a:p xmlns:a="http://schemas.openxmlformats.org/drawingml/2006/main"/>
+          <a:p xmlns:a="http://schemas.openxmlformats.org/drawingml/2006/main">
+            <a:r>
+              <a:t>The contribution is a physical construction-task prototype that separates task recognition from geometric command limits and examines objective behaviour alongside experience. We demonstrated the integration and obtained concrete findings: phase recognition at 79 percent, favourable reported experience, a stop-request chattering defect in the predictive policy, and a strong dependence of the results on the geometric reference. We have not established that predictive control improves safety or efficiency. The next comparison needs validated clearance and stopping measurements, the chattering fix, and reliable controller exposure per participant. Thank you; we welcome your questions.</a:t>
+            </a:r>
+          </a:p>
+          <a:p xmlns:a="http://schemas.openxmlformats.org/drawingml/2006/main"/>
+          <a:p xmlns:a="http://schemas.openxmlformats.org/drawingml/2006/main">
+            <a:r>
+              <a:t>Sources: paper Conclusion and Section VII.</a:t>
             </a:r>
           </a:p>
         </p:txBody>
@@ -912,24 +904,16 @@
               <a:t>Zenan | 45 seconds</a:t>
             </a:r>
           </a:p>
-          <a:p xmlns:a="http://schemas.openxmlformats.org/drawingml/2006/main">
-            <a:r>
-              <a:t/>
-            </a:r>
-          </a:p>
-          <a:p xmlns:a="http://schemas.openxmlformats.org/drawingml/2006/main">
-            <a:r>
-              <a:t>The laboratory system combines a UR10 robot, a lightweight panel surrogate and two tracking sources. Optical tracking supplies head position; the body-tracking suit supplies segment positions. The worker loads the panel, retreats before the lift, works near the raised panel, and retreats again before lowering. Robot position and joint motion are recorded alongside controller requests. This illustration explains the sequence; it is not experimental footage and does not simulate a measured safety outcome.</a:t>
-            </a:r>
-          </a:p>
-          <a:p xmlns:a="http://schemas.openxmlformats.org/drawingml/2006/main">
-            <a:r>
-              <a:t/>
-            </a:r>
-          </a:p>
-          <a:p xmlns:a="http://schemas.openxmlformats.org/drawingml/2006/main">
-            <a:r>
-              <a:t>Sources: Paper System Design and Experimental Method; docs/experiment_plan.md; existing scenario-poster.png. No video playback is required for the timed presentation.</a:t>
+          <a:p xmlns:a="http://schemas.openxmlformats.org/drawingml/2006/main"/>
+          <a:p xmlns:a="http://schemas.openxmlformats.org/drawingml/2006/main">
+            <a:r>
+              <a:t>This is the laboratory cell during a participant session. The UR10 holds the panel surrogate at ceiling height; the OptiTrack cameras are the units on the overhead frame, and they track a marker cluster on the participant's head cap. The participant also wears the Xsens suit, which gives us the position of 23 body segments. The worker loads the panel, retreats before the lift, works near the raised panel, and retreats again before lowering. Robot position and joint motion are recorded alongside controller requests. Faces are obscured in all footage we show.</a:t>
+            </a:r>
+          </a:p>
+          <a:p xmlns:a="http://schemas.openxmlformats.org/drawingml/2006/main"/>
+          <a:p xmlns:a="http://schemas.openxmlformats.org/drawingml/2006/main">
+            <a:r>
+              <a:t>Sources: paper Fig. 2 (apparatus), Section III-B Apparatus and Sensing.</a:t>
             </a:r>
           </a:p>
         </p:txBody>
@@ -1179,27 +1163,25 @@
           <a:lstStyle xmlns:a="http://schemas.openxmlformats.org/drawingml/2006/main"/>
           <a:p xmlns:a="http://schemas.openxmlformats.org/drawingml/2006/main">
             <a:r>
-              <a:t>Zenan | 40 seconds</a:t>
-            </a:r>
-          </a:p>
-          <a:p xmlns:a="http://schemas.openxmlformats.org/drawingml/2006/main">
-            <a:r>
-              <a:t/>
-            </a:r>
-          </a:p>
-          <a:p xmlns:a="http://schemas.openxmlformats.org/drawingml/2006/main">
-            <a:r>
-              <a:t>The model assigns each observation to one of three task phases. For the version that can operate online using only present and past observations, accuracy was 79.4 percent. Giving the three phases equal weight lowers the score to 72.5 percent, so the overall figure hides weaker performance outside the dominant working phase. Validation held out each of three development operators in turn across thirty-two accepted trials. These folds informed development, so this is a diagnostic result rather than an untouched deployment test. Recognition accuracy does not measure hazard detection or stopping safety.</a:t>
-            </a:r>
-          </a:p>
-          <a:p xmlns:a="http://schemas.openxmlformats.org/drawingml/2006/main">
-            <a:r>
-              <a:t/>
-            </a:r>
-          </a:p>
-          <a:p xmlns:a="http://schemas.openxmlformats.org/drawingml/2006/main">
-            <a:r>
-              <a:t>Sources: data/models/pilot_hmm.json validation.online_filter_accuracy and online_filter_balanced_accuracy; paper Model Development and Validation.</a:t>
+              <a:t>Zenan | 45 seconds</a:t>
+            </a:r>
+          </a:p>
+          <a:p xmlns:a="http://schemas.openxmlformats.org/drawingml/2006/main"/>
+          <a:p xmlns:a="http://schemas.openxmlformats.org/drawingml/2006/main">
+            <a:r>
+              <a:t>The model assigns each observation to one of three task phases. For the version that can operate online using only present and past observations, accuracy was 79.4 percent. Giving the three phases equal weight lowers the score to 72.5 percent, so the overall figure hides weaker performance outside the dominant working phase. Validation held out each of three development operators in turn across thirty-two accepted trials.</a:t>
+            </a:r>
+          </a:p>
+          <a:p xmlns:a="http://schemas.openxmlformats.org/drawingml/2006/main"/>
+          <a:p xmlns:a="http://schemas.openxmlformats.org/drawingml/2006/main">
+            <a:r>
+              <a:t>The cost of learned context showed up in the trials. The predictive controller issued between 15 and 73 protective-stop onsets per trial, against 6 to 9 for the fixed and reactive controllers, but only two or three per trial lasted a second or more. The rest were sub-half-second toggles near a threshold. It did not hold the robot stopped for longer; it switched the request far more often. That is a design defect we can fix with hysteresis or a minimum stop dwell on the learned inputs, without touching the deterministic envelope.</a:t>
+            </a:r>
+          </a:p>
+          <a:p xmlns:a="http://schemas.openxmlformats.org/drawingml/2006/main"/>
+          <a:p xmlns:a="http://schemas.openxmlformats.org/drawingml/2006/main">
+            <a:r>
+              <a:t>Sources: data/models/pilot_hmm.json validation; paper Table III stop-onset column and Section VII-A.</a:t>
             </a:r>
           </a:p>
         </p:txBody>
@@ -9687,7 +9669,7 @@
                 <a:ea typeface="Arial"/>
                 <a:cs typeface="Arial"/>
               </a:rPr>
-              <a:t>Task recognition worked imperfectly. Reported experience</a:t>
+              <a:t>Recognition worked imperfectly; the predictive policy chattered its stop request.</a:t>
             </a:r>
           </a:p>
           <a:p xmlns:a="http://schemas.openxmlformats.org/drawingml/2006/main">
@@ -9710,7 +9692,7 @@
                 <a:ea typeface="Arial"/>
                 <a:cs typeface="Arial"/>
               </a:rPr>
-              <a:t>was generally favourable. Geometry strongly affected interpretation.</a:t>
+              <a:t>Reported experience was favourable. Geometry shaped interpretation.</a:t>
             </a:r>
           </a:p>
         </p:txBody>
@@ -12296,7 +12278,7 @@
         </p:nvSpPr>
         <p:spPr>
           <a:xfrm xmlns:a="http://schemas.openxmlformats.org/drawingml/2006/main">
-            <a:off x="571500" y="5257800"/>
+            <a:off x="571500" y="4877800"/>
             <a:ext cx="10858500" cy="628650"/>
           </a:xfrm>
           <a:prstGeom xmlns:a="http://schemas.openxmlformats.org/drawingml/2006/main" prst="rect">
@@ -12355,7 +12337,7 @@
                 <a:ea typeface="Arial"/>
                 <a:cs typeface="Arial"/>
               </a:rPr>
-              <a:t>These are development results, not a physical safety score.</a:t>
+              <a:t>Predictive policy: 15 to 73 stop onsets per trial vs 6 to 9 for fixed/reactive, nearly all under 0.5 s. Chattering, not longer stops.</a:t>
             </a:r>
           </a:p>
         </p:txBody>

</xml_diff>